<commit_message>
Add a transparently-labeled exploratory subset comparison for the global pool
Adds one new slide (8/12) to the LOYO-CV deck answering "how much does
performance improve in a best-case subset" honestly: the full 68-pixel
pool (primary, reported result, mean R2=0.348) shown side by side with
the top 20 pixels ranked by their own mean LOYO-CV R2 (mean R2=0.690),
with the exact selection rule stated, the subset explicitly labeled
EXPLORATORY, and a visible warning that subset statistics are conditional
on performance-based selection and not representative of the full pool.

The full-pool result remains the primary, reported finding everywhere
else in this project - this slide only adds a clearly-scoped answer to a
narrower question, it does not replace or reframe the overall result.

Co-Authored-By: Claude Sonnet 5 <noreply@anthropic.com>
</commit_message>
<xml_diff>
--- a/presentations/LOYO_CV_Robustness_Update/LOYO_CV_Robustness_Update.pptx
+++ b/presentations/LOYO_CV_Robustness_Update/LOYO_CV_Robustness_Update.pptx
@@ -16,6 +16,7 @@
     <p:sldId id="264" r:id="rId15"/>
     <p:sldId id="265" r:id="rId16"/>
     <p:sldId id="266" r:id="rId17"/>
+    <p:sldId id="267" r:id="rId18"/>
   </p:sldIdLst>
   <p:sldSz cx="12191695" cy="6858000" type="screen4x3"/>
   <p:notesSz cx="6858000" cy="9144000"/>
@@ -3639,7 +3640,7 @@
                 </a:solidFill>
                 <a:latin typeface="Calibri"/>
               </a:rPr>
-              <a:t>Is Any Single Year Uniformly Hard?</a:t>
+              <a:t>CONUS vs. Global: Variance Comparison</a:t>
             </a:r>
           </a:p>
         </p:txBody>
@@ -3729,7 +3730,7 @@
       </p:sp>
       <p:pic>
         <p:nvPicPr>
-          <p:cNvPr id="6" name="Picture 5" descr="loyo_r2_by_year.png"/>
+          <p:cNvPr id="6" name="Picture 5" descr="loyo_variance_comparison.png"/>
           <p:cNvPicPr>
             <a:picLocks noChangeAspect="1"/>
           </p:cNvPicPr>
@@ -3743,8 +3744,8 @@
         </p:blipFill>
         <p:spPr>
           <a:xfrm>
-            <a:off x="1713761" y="1143000"/>
-            <a:ext cx="8764172" cy="4864608"/>
+            <a:off x="502920" y="1152603"/>
+            <a:ext cx="11185855" cy="4845402"/>
           </a:xfrm>
           <a:prstGeom prst="rect">
             <a:avLst/>
@@ -3912,7 +3913,7 @@
                 </a:solidFill>
                 <a:latin typeface="Calibri"/>
               </a:rPr>
-              <a:t>No — median R² across pixels stays consistently high in every one of the 11 held-out years for both pools. Individual-pixel bad folds (e.g. droughts) don't show up as population-wide crashes.</a:t>
+              <a:t>Typical variance is lower for CONUS (0.005 vs. Global's 0.030) — but CONUS has a longer extreme-outlier tail (e.g. evergreen's 2012 drought fold).</a:t>
             </a:r>
           </a:p>
         </p:txBody>
@@ -3977,7 +3978,7 @@
                 </a:solidFill>
                 <a:latin typeface="Calibri"/>
               </a:rPr>
-              <a:t>SUMMARY</a:t>
+              <a:t>INTEGRATING BOTH POOLS</a:t>
             </a:r>
           </a:p>
         </p:txBody>
@@ -4016,7 +4017,7 @@
                 </a:solidFill>
                 <a:latin typeface="Calibri"/>
               </a:rPr>
-              <a:t>Summary: What LOYO-CV Adds</a:t>
+              <a:t>Is Any Single Year Uniformly Hard?</a:t>
             </a:r>
           </a:p>
         </p:txBody>
@@ -4100,6 +4101,383 @@
                 <a:latin typeface="Calibri"/>
               </a:rPr>
               <a:t>11</a:t>
+            </a:r>
+          </a:p>
+        </p:txBody>
+      </p:sp>
+      <p:pic>
+        <p:nvPicPr>
+          <p:cNvPr id="6" name="Picture 5" descr="loyo_r2_by_year.png"/>
+          <p:cNvPicPr>
+            <a:picLocks noChangeAspect="1"/>
+          </p:cNvPicPr>
+          <p:nvPr/>
+        </p:nvPicPr>
+        <p:blipFill>
+          <a:blip r:embed="rId2"/>
+          <a:stretch>
+            <a:fillRect/>
+          </a:stretch>
+        </p:blipFill>
+        <p:spPr>
+          <a:xfrm>
+            <a:off x="1713761" y="1143000"/>
+            <a:ext cx="8764172" cy="4864608"/>
+          </a:xfrm>
+          <a:prstGeom prst="rect">
+            <a:avLst/>
+          </a:prstGeom>
+        </p:spPr>
+      </p:pic>
+      <p:sp>
+        <p:nvSpPr>
+          <p:cNvPr id="7" name="Rectangle 6"/>
+          <p:cNvSpPr/>
+          <p:nvPr/>
+        </p:nvSpPr>
+        <p:spPr>
+          <a:xfrm>
+            <a:off x="0" y="6144768"/>
+            <a:ext cx="12191695" cy="713232"/>
+          </a:xfrm>
+          <a:prstGeom prst="rect">
+            <a:avLst/>
+          </a:prstGeom>
+          <a:solidFill>
+            <a:srgbClr val="E7F0E6"/>
+          </a:solidFill>
+          <a:ln>
+            <a:noFill/>
+          </a:ln>
+          <a:effectLst/>
+        </p:spPr>
+        <p:style>
+          <a:lnRef idx="1">
+            <a:schemeClr val="accent1"/>
+          </a:lnRef>
+          <a:fillRef idx="3">
+            <a:schemeClr val="accent1"/>
+          </a:fillRef>
+          <a:effectRef idx="2">
+            <a:schemeClr val="accent1"/>
+          </a:effectRef>
+          <a:fontRef idx="minor">
+            <a:schemeClr val="lt1"/>
+          </a:fontRef>
+        </p:style>
+        <p:txBody>
+          <a:bodyPr rtlCol="0" anchor="ctr"/>
+          <a:lstStyle/>
+          <a:p>
+            <a:pPr algn="ctr"/>
+          </a:p>
+        </p:txBody>
+      </p:sp>
+      <p:sp>
+        <p:nvSpPr>
+          <p:cNvPr id="8" name="Rectangle 7"/>
+          <p:cNvSpPr/>
+          <p:nvPr/>
+        </p:nvSpPr>
+        <p:spPr>
+          <a:xfrm>
+            <a:off x="0" y="6144768"/>
+            <a:ext cx="109728" cy="713232"/>
+          </a:xfrm>
+          <a:prstGeom prst="rect">
+            <a:avLst/>
+          </a:prstGeom>
+          <a:solidFill>
+            <a:srgbClr val="2F6F5E"/>
+          </a:solidFill>
+          <a:ln>
+            <a:noFill/>
+          </a:ln>
+          <a:effectLst/>
+        </p:spPr>
+        <p:style>
+          <a:lnRef idx="1">
+            <a:schemeClr val="accent1"/>
+          </a:lnRef>
+          <a:fillRef idx="3">
+            <a:schemeClr val="accent1"/>
+          </a:fillRef>
+          <a:effectRef idx="2">
+            <a:schemeClr val="accent1"/>
+          </a:effectRef>
+          <a:fontRef idx="minor">
+            <a:schemeClr val="lt1"/>
+          </a:fontRef>
+        </p:style>
+        <p:txBody>
+          <a:bodyPr rtlCol="0" anchor="ctr"/>
+          <a:lstStyle/>
+          <a:p>
+            <a:pPr algn="ctr"/>
+          </a:p>
+        </p:txBody>
+      </p:sp>
+      <p:sp>
+        <p:nvSpPr>
+          <p:cNvPr id="9" name="TextBox 8"/>
+          <p:cNvSpPr txBox="1"/>
+          <p:nvPr/>
+        </p:nvSpPr>
+        <p:spPr>
+          <a:xfrm>
+            <a:off x="411480" y="6144768"/>
+            <a:ext cx="11368735" cy="713232"/>
+          </a:xfrm>
+          <a:prstGeom prst="rect">
+            <a:avLst/>
+          </a:prstGeom>
+          <a:noFill/>
+        </p:spPr>
+        <p:txBody>
+          <a:bodyPr wrap="square" anchor="ctr" lIns="0" rIns="0" tIns="0" bIns="0">
+            <a:spAutoFit/>
+          </a:bodyPr>
+          <a:lstStyle/>
+          <a:p>
+            <a:pPr algn="l">
+              <a:lnSpc>
+                <a:spcPct val="100000"/>
+              </a:lnSpc>
+            </a:pPr>
+            <a:r>
+              <a:rPr sz="1200" b="1" i="0">
+                <a:solidFill>
+                  <a:srgbClr val="1E4A33"/>
+                </a:solidFill>
+                <a:latin typeface="Calibri"/>
+              </a:rPr>
+              <a:t>TAKEAWAY   </a:t>
+            </a:r>
+          </a:p>
+        </p:txBody>
+      </p:sp>
+      <p:sp>
+        <p:nvSpPr>
+          <p:cNvPr id="10" name="TextBox 9"/>
+          <p:cNvSpPr txBox="1"/>
+          <p:nvPr/>
+        </p:nvSpPr>
+        <p:spPr>
+          <a:xfrm>
+            <a:off x="1417320" y="6144768"/>
+            <a:ext cx="10362895" cy="713232"/>
+          </a:xfrm>
+          <a:prstGeom prst="rect">
+            <a:avLst/>
+          </a:prstGeom>
+          <a:noFill/>
+        </p:spPr>
+        <p:txBody>
+          <a:bodyPr wrap="square" anchor="ctr" lIns="0" rIns="0" tIns="0" bIns="0">
+            <a:spAutoFit/>
+          </a:bodyPr>
+          <a:lstStyle/>
+          <a:p>
+            <a:pPr algn="l">
+              <a:lnSpc>
+                <a:spcPct val="100000"/>
+              </a:lnSpc>
+            </a:pPr>
+            <a:r>
+              <a:rPr sz="1450" b="1" i="0">
+                <a:solidFill>
+                  <a:srgbClr val="1E4A33"/>
+                </a:solidFill>
+                <a:latin typeface="Calibri"/>
+              </a:rPr>
+              <a:t>No — median R² across pixels stays consistently high in every one of the 11 held-out years for both pools. Individual-pixel bad folds (e.g. droughts) don't show up as population-wide crashes.</a:t>
+            </a:r>
+          </a:p>
+        </p:txBody>
+      </p:sp>
+    </p:spTree>
+  </p:cSld>
+  <p:clrMapOvr>
+    <a:masterClrMapping/>
+  </p:clrMapOvr>
+</p:sld>
+</file>
+
+<file path=ppt/slides/slide12.xml><?xml version="1.0" encoding="utf-8"?>
+<p:sld xmlns:a="http://schemas.openxmlformats.org/drawingml/2006/main" xmlns:p="http://schemas.openxmlformats.org/presentationml/2006/main" xmlns:r="http://schemas.openxmlformats.org/officeDocument/2006/relationships">
+  <p:cSld>
+    <p:bg>
+      <p:bgPr>
+        <a:solidFill>
+          <a:srgbClr val="FFFFFF"/>
+        </a:solidFill>
+        <a:effectLst/>
+      </p:bgPr>
+    </p:bg>
+    <p:spTree>
+      <p:nvGrpSpPr>
+        <p:cNvPr id="1" name=""/>
+        <p:cNvGrpSpPr/>
+        <p:nvPr/>
+      </p:nvGrpSpPr>
+      <p:grpSpPr/>
+      <p:sp>
+        <p:nvSpPr>
+          <p:cNvPr id="2" name="TextBox 1"/>
+          <p:cNvSpPr txBox="1"/>
+          <p:nvPr/>
+        </p:nvSpPr>
+        <p:spPr>
+          <a:xfrm>
+            <a:off x="502920" y="384048"/>
+            <a:ext cx="10972800" cy="292608"/>
+          </a:xfrm>
+          <a:prstGeom prst="rect">
+            <a:avLst/>
+          </a:prstGeom>
+          <a:noFill/>
+        </p:spPr>
+        <p:txBody>
+          <a:bodyPr wrap="square" anchor="t" lIns="0" rIns="0" tIns="0" bIns="0">
+            <a:spAutoFit/>
+          </a:bodyPr>
+          <a:lstStyle/>
+          <a:p>
+            <a:pPr algn="l">
+              <a:lnSpc>
+                <a:spcPct val="100000"/>
+              </a:lnSpc>
+            </a:pPr>
+            <a:r>
+              <a:rPr sz="1300" b="1" i="0">
+                <a:solidFill>
+                  <a:srgbClr val="2F6F5E"/>
+                </a:solidFill>
+                <a:latin typeface="Calibri"/>
+              </a:rPr>
+              <a:t>SUMMARY</a:t>
+            </a:r>
+          </a:p>
+        </p:txBody>
+      </p:sp>
+      <p:sp>
+        <p:nvSpPr>
+          <p:cNvPr id="3" name="TextBox 2"/>
+          <p:cNvSpPr txBox="1"/>
+          <p:nvPr/>
+        </p:nvSpPr>
+        <p:spPr>
+          <a:xfrm>
+            <a:off x="502920" y="658368"/>
+            <a:ext cx="11155680" cy="566928"/>
+          </a:xfrm>
+          <a:prstGeom prst="rect">
+            <a:avLst/>
+          </a:prstGeom>
+          <a:noFill/>
+        </p:spPr>
+        <p:txBody>
+          <a:bodyPr wrap="square" anchor="t" lIns="0" rIns="0" tIns="0" bIns="0">
+            <a:spAutoFit/>
+          </a:bodyPr>
+          <a:lstStyle/>
+          <a:p>
+            <a:pPr algn="l">
+              <a:lnSpc>
+                <a:spcPct val="100000"/>
+              </a:lnSpc>
+            </a:pPr>
+            <a:r>
+              <a:rPr sz="2300" b="1" i="0">
+                <a:solidFill>
+                  <a:srgbClr val="1C2119"/>
+                </a:solidFill>
+                <a:latin typeface="Calibri"/>
+              </a:rPr>
+              <a:t>Summary: What LOYO-CV Adds</a:t>
+            </a:r>
+          </a:p>
+        </p:txBody>
+      </p:sp>
+      <p:sp>
+        <p:nvSpPr>
+          <p:cNvPr id="4" name="Rectangle 3"/>
+          <p:cNvSpPr/>
+          <p:nvPr/>
+        </p:nvSpPr>
+        <p:spPr>
+          <a:xfrm>
+            <a:off x="502920" y="1261872"/>
+            <a:ext cx="914400" cy="38100"/>
+          </a:xfrm>
+          <a:prstGeom prst="rect">
+            <a:avLst/>
+          </a:prstGeom>
+          <a:solidFill>
+            <a:srgbClr val="2F6F5E"/>
+          </a:solidFill>
+          <a:ln>
+            <a:noFill/>
+          </a:ln>
+          <a:effectLst/>
+        </p:spPr>
+        <p:style>
+          <a:lnRef idx="1">
+            <a:schemeClr val="accent1"/>
+          </a:lnRef>
+          <a:fillRef idx="3">
+            <a:schemeClr val="accent1"/>
+          </a:fillRef>
+          <a:effectRef idx="2">
+            <a:schemeClr val="accent1"/>
+          </a:effectRef>
+          <a:fontRef idx="minor">
+            <a:schemeClr val="lt1"/>
+          </a:fontRef>
+        </p:style>
+        <p:txBody>
+          <a:bodyPr rtlCol="0" anchor="ctr"/>
+          <a:lstStyle/>
+          <a:p>
+            <a:pPr algn="ctr"/>
+          </a:p>
+        </p:txBody>
+      </p:sp>
+      <p:sp>
+        <p:nvSpPr>
+          <p:cNvPr id="5" name="TextBox 4"/>
+          <p:cNvSpPr txBox="1"/>
+          <p:nvPr/>
+        </p:nvSpPr>
+        <p:spPr>
+          <a:xfrm>
+            <a:off x="11551615" y="384048"/>
+            <a:ext cx="365760" cy="274320"/>
+          </a:xfrm>
+          <a:prstGeom prst="rect">
+            <a:avLst/>
+          </a:prstGeom>
+          <a:noFill/>
+        </p:spPr>
+        <p:txBody>
+          <a:bodyPr wrap="square" anchor="t" lIns="0" rIns="0" tIns="0" bIns="0">
+            <a:spAutoFit/>
+          </a:bodyPr>
+          <a:lstStyle/>
+          <a:p>
+            <a:pPr algn="r">
+              <a:lnSpc>
+                <a:spcPct val="100000"/>
+              </a:lnSpc>
+            </a:pPr>
+            <a:r>
+              <a:rPr sz="1100" b="0" i="0">
+                <a:solidFill>
+                  <a:srgbClr val="8B9382"/>
+                </a:solidFill>
+                <a:latin typeface="Calibri"/>
+              </a:rPr>
+              <a:t>12</a:t>
             </a:r>
           </a:p>
         </p:txBody>
@@ -8997,7 +9375,7 @@
                 </a:solidFill>
                 <a:latin typeface="Calibri"/>
               </a:rPr>
-              <a:t>SECTION 2 — GLOBAL ROBUSTNESS CHECK</a:t>
+              <a:t>SECTION 2 — GLOBAL (NON-CONUS) EXPERIMENT</a:t>
             </a:r>
           </a:p>
         </p:txBody>
@@ -9036,7 +9414,7 @@
                 </a:solidFill>
                 <a:latin typeface="Calibri"/>
               </a:rPr>
-              <a:t>Global 68-Pixel Pool: LOYO-CV Results</a:t>
+              <a:t>Full Pool vs. an Exploratory Performance-Selected Subset</a:t>
             </a:r>
           </a:p>
         </p:txBody>
@@ -9126,60 +9504,14 @@
       </p:sp>
       <p:sp>
         <p:nvSpPr>
-          <p:cNvPr id="6" name="Rounded Rectangle 5"/>
-          <p:cNvSpPr/>
+          <p:cNvPr id="6" name="TextBox 5"/>
+          <p:cNvSpPr txBox="1"/>
           <p:nvPr/>
         </p:nvSpPr>
         <p:spPr>
           <a:xfrm>
             <a:off x="502920" y="1143000"/>
-            <a:ext cx="2514600" cy="1005840"/>
-          </a:xfrm>
-          <a:prstGeom prst="roundRect">
-            <a:avLst>
-              <a:gd name="adj" fmla="val 12000"/>
-            </a:avLst>
-          </a:prstGeom>
-          <a:solidFill>
-            <a:srgbClr val="F3E2E8"/>
-          </a:solidFill>
-          <a:ln>
-            <a:noFill/>
-          </a:ln>
-          <a:effectLst/>
-        </p:spPr>
-        <p:style>
-          <a:lnRef idx="1">
-            <a:schemeClr val="accent1"/>
-          </a:lnRef>
-          <a:fillRef idx="3">
-            <a:schemeClr val="accent1"/>
-          </a:fillRef>
-          <a:effectRef idx="2">
-            <a:schemeClr val="accent1"/>
-          </a:effectRef>
-          <a:fontRef idx="minor">
-            <a:schemeClr val="lt1"/>
-          </a:fontRef>
-        </p:style>
-        <p:txBody>
-          <a:bodyPr rtlCol="0" anchor="ctr"/>
-          <a:lstStyle/>
-          <a:p>
-            <a:pPr algn="ctr"/>
-          </a:p>
-        </p:txBody>
-      </p:sp>
-      <p:sp>
-        <p:nvSpPr>
-          <p:cNvPr id="7" name="TextBox 6"/>
-          <p:cNvSpPr txBox="1"/>
-          <p:nvPr/>
-        </p:nvSpPr>
-        <p:spPr>
-          <a:xfrm>
-            <a:off x="502920" y="1252728"/>
-            <a:ext cx="2514600" cy="502920"/>
+            <a:ext cx="10789920" cy="502920"/>
           </a:xfrm>
           <a:prstGeom prst="rect">
             <a:avLst/>
@@ -9192,23 +9524,473 @@
           </a:bodyPr>
           <a:lstStyle/>
           <a:p>
-            <a:pPr algn="ctr">
+            <a:pPr algn="l">
               <a:lnSpc>
                 <a:spcPct val="100000"/>
               </a:lnSpc>
             </a:pPr>
             <a:r>
-              <a:rPr sz="2600" b="1" i="0">
-                <a:solidFill>
-                  <a:srgbClr val="6B1A33"/>
-                </a:solidFill>
-                <a:latin typeface="Calibri"/>
-              </a:rPr>
-              <a:t>0.348</a:t>
-            </a:r>
-          </a:p>
-        </p:txBody>
-      </p:sp>
+              <a:rPr sz="1350" b="0" i="0">
+                <a:solidFill>
+                  <a:srgbClr val="5C6355"/>
+                </a:solidFill>
+                <a:latin typeface="Calibri"/>
+              </a:rPr>
+              <a:t>Question: how much does performance improve in a best-case subset? Answered transparently — this is exploratory, not a second estimate of the overall result.</a:t>
+            </a:r>
+          </a:p>
+        </p:txBody>
+      </p:sp>
+      <p:graphicFrame>
+        <p:nvGraphicFramePr>
+          <p:cNvPr id="7" name="Table 6"/>
+          <p:cNvGraphicFramePr>
+            <a:graphicFrameLocks noGrp="1"/>
+          </p:cNvGraphicFramePr>
+          <p:nvPr/>
+        </p:nvGraphicFramePr>
+        <p:xfrm>
+          <a:off x="502920" y="1737360"/>
+          <a:ext cx="11185852" cy="1051560"/>
+        </p:xfrm>
+        <a:graphic>
+          <a:graphicData uri="http://schemas.openxmlformats.org/drawingml/2006/table">
+            <a:tbl>
+              <a:tblPr firstRow="1" bandRow="1">
+                <a:tableStyleId>{5C22544A-7EE6-4342-B048-85BDC9FD1C3A}</a:tableStyleId>
+              </a:tblPr>
+              <a:tblGrid>
+                <a:gridCol w="3803190"/>
+                <a:gridCol w="894868"/>
+                <a:gridCol w="1677878"/>
+                <a:gridCol w="1677878"/>
+                <a:gridCol w="1566019"/>
+                <a:gridCol w="1566019"/>
+              </a:tblGrid>
+              <a:tr h="350520">
+                <a:tc>
+                  <a:txBody>
+                    <a:bodyPr/>
+                    <a:lstStyle/>
+                    <a:p>
+                      <a:pPr algn="l"/>
+                      <a:r>
+                        <a:rPr sz="1200" b="1">
+                          <a:solidFill>
+                            <a:srgbClr val="FFFFFF"/>
+                          </a:solidFill>
+                          <a:latin typeface="Calibri"/>
+                        </a:rPr>
+                        <a:t>Group</a:t>
+                      </a:r>
+                    </a:p>
+                  </a:txBody>
+                  <a:tcPr marT="38100" marB="38100">
+                    <a:solidFill>
+                      <a:srgbClr val="8C1D40"/>
+                    </a:solidFill>
+                  </a:tcPr>
+                </a:tc>
+                <a:tc>
+                  <a:txBody>
+                    <a:bodyPr/>
+                    <a:lstStyle/>
+                    <a:p>
+                      <a:pPr algn="ctr"/>
+                      <a:r>
+                        <a:rPr sz="1200" b="1">
+                          <a:solidFill>
+                            <a:srgbClr val="FFFFFF"/>
+                          </a:solidFill>
+                          <a:latin typeface="Calibri"/>
+                        </a:rPr>
+                        <a:t>n</a:t>
+                      </a:r>
+                    </a:p>
+                  </a:txBody>
+                  <a:tcPr marT="38100" marB="38100">
+                    <a:solidFill>
+                      <a:srgbClr val="8C1D40"/>
+                    </a:solidFill>
+                  </a:tcPr>
+                </a:tc>
+                <a:tc>
+                  <a:txBody>
+                    <a:bodyPr/>
+                    <a:lstStyle/>
+                    <a:p>
+                      <a:pPr algn="ctr"/>
+                      <a:r>
+                        <a:rPr sz="1200" b="1">
+                          <a:solidFill>
+                            <a:srgbClr val="FFFFFF"/>
+                          </a:solidFill>
+                          <a:latin typeface="Calibri"/>
+                        </a:rPr>
+                        <a:t>Mean R²</a:t>
+                      </a:r>
+                    </a:p>
+                  </a:txBody>
+                  <a:tcPr marT="38100" marB="38100">
+                    <a:solidFill>
+                      <a:srgbClr val="8C1D40"/>
+                    </a:solidFill>
+                  </a:tcPr>
+                </a:tc>
+                <a:tc>
+                  <a:txBody>
+                    <a:bodyPr/>
+                    <a:lstStyle/>
+                    <a:p>
+                      <a:pPr algn="ctr"/>
+                      <a:r>
+                        <a:rPr sz="1200" b="1">
+                          <a:solidFill>
+                            <a:srgbClr val="FFFFFF"/>
+                          </a:solidFill>
+                          <a:latin typeface="Calibri"/>
+                        </a:rPr>
+                        <a:t>Median R²</a:t>
+                      </a:r>
+                    </a:p>
+                  </a:txBody>
+                  <a:tcPr marT="38100" marB="38100">
+                    <a:solidFill>
+                      <a:srgbClr val="8C1D40"/>
+                    </a:solidFill>
+                  </a:tcPr>
+                </a:tc>
+                <a:tc>
+                  <a:txBody>
+                    <a:bodyPr/>
+                    <a:lstStyle/>
+                    <a:p>
+                      <a:pPr algn="ctr"/>
+                      <a:r>
+                        <a:rPr sz="1200" b="1">
+                          <a:solidFill>
+                            <a:srgbClr val="FFFFFF"/>
+                          </a:solidFill>
+                          <a:latin typeface="Calibri"/>
+                        </a:rPr>
+                        <a:t>Avg. variance</a:t>
+                      </a:r>
+                    </a:p>
+                  </a:txBody>
+                  <a:tcPr marT="38100" marB="38100">
+                    <a:solidFill>
+                      <a:srgbClr val="8C1D40"/>
+                    </a:solidFill>
+                  </a:tcPr>
+                </a:tc>
+                <a:tc>
+                  <a:txBody>
+                    <a:bodyPr/>
+                    <a:lstStyle/>
+                    <a:p>
+                      <a:pPr algn="ctr"/>
+                      <a:r>
+                        <a:rPr sz="1200" b="1">
+                          <a:solidFill>
+                            <a:srgbClr val="FFFFFF"/>
+                          </a:solidFill>
+                          <a:latin typeface="Calibri"/>
+                        </a:rPr>
+                        <a:t>Median variance</a:t>
+                      </a:r>
+                    </a:p>
+                  </a:txBody>
+                  <a:tcPr marT="38100" marB="38100">
+                    <a:solidFill>
+                      <a:srgbClr val="8C1D40"/>
+                    </a:solidFill>
+                  </a:tcPr>
+                </a:tc>
+              </a:tr>
+              <a:tr h="350520">
+                <a:tc>
+                  <a:txBody>
+                    <a:bodyPr/>
+                    <a:lstStyle/>
+                    <a:p>
+                      <a:pPr algn="l"/>
+                      <a:r>
+                        <a:rPr sz="1200" b="1">
+                          <a:solidFill>
+                            <a:srgbClr val="1C2119"/>
+                          </a:solidFill>
+                          <a:latin typeface="Calibri"/>
+                        </a:rPr>
+                        <a:t>Full global pool — PRIMARY RESULT</a:t>
+                      </a:r>
+                    </a:p>
+                  </a:txBody>
+                  <a:tcPr marT="38100" marB="38100">
+                    <a:solidFill>
+                      <a:srgbClr val="FFFFFF"/>
+                    </a:solidFill>
+                  </a:tcPr>
+                </a:tc>
+                <a:tc>
+                  <a:txBody>
+                    <a:bodyPr/>
+                    <a:lstStyle/>
+                    <a:p>
+                      <a:pPr algn="ctr"/>
+                      <a:r>
+                        <a:rPr sz="1200" b="0">
+                          <a:solidFill>
+                            <a:srgbClr val="1C2119"/>
+                          </a:solidFill>
+                          <a:latin typeface="Calibri"/>
+                        </a:rPr>
+                        <a:t>68</a:t>
+                      </a:r>
+                    </a:p>
+                  </a:txBody>
+                  <a:tcPr marT="38100" marB="38100">
+                    <a:solidFill>
+                      <a:srgbClr val="FFFFFF"/>
+                    </a:solidFill>
+                  </a:tcPr>
+                </a:tc>
+                <a:tc>
+                  <a:txBody>
+                    <a:bodyPr/>
+                    <a:lstStyle/>
+                    <a:p>
+                      <a:pPr algn="ctr"/>
+                      <a:r>
+                        <a:rPr sz="1200" b="0">
+                          <a:solidFill>
+                            <a:srgbClr val="1C2119"/>
+                          </a:solidFill>
+                          <a:latin typeface="Calibri"/>
+                        </a:rPr>
+                        <a:t>0.348</a:t>
+                      </a:r>
+                    </a:p>
+                  </a:txBody>
+                  <a:tcPr marT="38100" marB="38100">
+                    <a:solidFill>
+                      <a:srgbClr val="FFFFFF"/>
+                    </a:solidFill>
+                  </a:tcPr>
+                </a:tc>
+                <a:tc>
+                  <a:txBody>
+                    <a:bodyPr/>
+                    <a:lstStyle/>
+                    <a:p>
+                      <a:pPr algn="ctr"/>
+                      <a:r>
+                        <a:rPr sz="1200" b="0">
+                          <a:solidFill>
+                            <a:srgbClr val="1C2119"/>
+                          </a:solidFill>
+                          <a:latin typeface="Calibri"/>
+                        </a:rPr>
+                        <a:t>0.393</a:t>
+                      </a:r>
+                    </a:p>
+                  </a:txBody>
+                  <a:tcPr marT="38100" marB="38100">
+                    <a:solidFill>
+                      <a:srgbClr val="FFFFFF"/>
+                    </a:solidFill>
+                  </a:tcPr>
+                </a:tc>
+                <a:tc>
+                  <a:txBody>
+                    <a:bodyPr/>
+                    <a:lstStyle/>
+                    <a:p>
+                      <a:pPr algn="ctr"/>
+                      <a:r>
+                        <a:rPr sz="1200" b="0">
+                          <a:solidFill>
+                            <a:srgbClr val="1C2119"/>
+                          </a:solidFill>
+                          <a:latin typeface="Calibri"/>
+                        </a:rPr>
+                        <a:t>0.106</a:t>
+                      </a:r>
+                    </a:p>
+                  </a:txBody>
+                  <a:tcPr marT="38100" marB="38100">
+                    <a:solidFill>
+                      <a:srgbClr val="FFFFFF"/>
+                    </a:solidFill>
+                  </a:tcPr>
+                </a:tc>
+                <a:tc>
+                  <a:txBody>
+                    <a:bodyPr/>
+                    <a:lstStyle/>
+                    <a:p>
+                      <a:pPr algn="ctr"/>
+                      <a:r>
+                        <a:rPr sz="1200" b="0">
+                          <a:solidFill>
+                            <a:srgbClr val="1C2119"/>
+                          </a:solidFill>
+                          <a:latin typeface="Calibri"/>
+                        </a:rPr>
+                        <a:t>0.030</a:t>
+                      </a:r>
+                    </a:p>
+                  </a:txBody>
+                  <a:tcPr marT="38100" marB="38100">
+                    <a:solidFill>
+                      <a:srgbClr val="FFFFFF"/>
+                    </a:solidFill>
+                  </a:tcPr>
+                </a:tc>
+              </a:tr>
+              <a:tr h="350520">
+                <a:tc>
+                  <a:txBody>
+                    <a:bodyPr/>
+                    <a:lstStyle/>
+                    <a:p>
+                      <a:pPr algn="l"/>
+                      <a:r>
+                        <a:rPr sz="1200" b="1">
+                          <a:solidFill>
+                            <a:srgbClr val="1C2119"/>
+                          </a:solidFill>
+                          <a:latin typeface="Calibri"/>
+                        </a:rPr>
+                        <a:t>Top-20 by mean R² — EXPLORATORY</a:t>
+                      </a:r>
+                    </a:p>
+                  </a:txBody>
+                  <a:tcPr marT="38100" marB="38100">
+                    <a:solidFill>
+                      <a:srgbClr val="E7F0E6"/>
+                    </a:solidFill>
+                  </a:tcPr>
+                </a:tc>
+                <a:tc>
+                  <a:txBody>
+                    <a:bodyPr/>
+                    <a:lstStyle/>
+                    <a:p>
+                      <a:pPr algn="ctr"/>
+                      <a:r>
+                        <a:rPr sz="1200" b="1">
+                          <a:solidFill>
+                            <a:srgbClr val="1C2119"/>
+                          </a:solidFill>
+                          <a:latin typeface="Calibri"/>
+                        </a:rPr>
+                        <a:t>20</a:t>
+                      </a:r>
+                    </a:p>
+                  </a:txBody>
+                  <a:tcPr marT="38100" marB="38100">
+                    <a:solidFill>
+                      <a:srgbClr val="E7F0E6"/>
+                    </a:solidFill>
+                  </a:tcPr>
+                </a:tc>
+                <a:tc>
+                  <a:txBody>
+                    <a:bodyPr/>
+                    <a:lstStyle/>
+                    <a:p>
+                      <a:pPr algn="ctr"/>
+                      <a:r>
+                        <a:rPr sz="1200" b="1">
+                          <a:solidFill>
+                            <a:srgbClr val="1C2119"/>
+                          </a:solidFill>
+                          <a:latin typeface="Calibri"/>
+                        </a:rPr>
+                        <a:t>0.690</a:t>
+                      </a:r>
+                    </a:p>
+                  </a:txBody>
+                  <a:tcPr marT="38100" marB="38100">
+                    <a:solidFill>
+                      <a:srgbClr val="E7F0E6"/>
+                    </a:solidFill>
+                  </a:tcPr>
+                </a:tc>
+                <a:tc>
+                  <a:txBody>
+                    <a:bodyPr/>
+                    <a:lstStyle/>
+                    <a:p>
+                      <a:pPr algn="ctr"/>
+                      <a:r>
+                        <a:rPr sz="1200" b="1">
+                          <a:solidFill>
+                            <a:srgbClr val="1C2119"/>
+                          </a:solidFill>
+                          <a:latin typeface="Calibri"/>
+                        </a:rPr>
+                        <a:t>0.710</a:t>
+                      </a:r>
+                    </a:p>
+                  </a:txBody>
+                  <a:tcPr marT="38100" marB="38100">
+                    <a:solidFill>
+                      <a:srgbClr val="E7F0E6"/>
+                    </a:solidFill>
+                  </a:tcPr>
+                </a:tc>
+                <a:tc>
+                  <a:txBody>
+                    <a:bodyPr/>
+                    <a:lstStyle/>
+                    <a:p>
+                      <a:pPr algn="ctr"/>
+                      <a:r>
+                        <a:rPr sz="1200" b="1">
+                          <a:solidFill>
+                            <a:srgbClr val="1C2119"/>
+                          </a:solidFill>
+                          <a:latin typeface="Calibri"/>
+                        </a:rPr>
+                        <a:t>0.022</a:t>
+                      </a:r>
+                    </a:p>
+                  </a:txBody>
+                  <a:tcPr marT="38100" marB="38100">
+                    <a:solidFill>
+                      <a:srgbClr val="E7F0E6"/>
+                    </a:solidFill>
+                  </a:tcPr>
+                </a:tc>
+                <a:tc>
+                  <a:txBody>
+                    <a:bodyPr/>
+                    <a:lstStyle/>
+                    <a:p>
+                      <a:pPr algn="ctr"/>
+                      <a:r>
+                        <a:rPr sz="1200" b="1">
+                          <a:solidFill>
+                            <a:srgbClr val="1C2119"/>
+                          </a:solidFill>
+                          <a:latin typeface="Calibri"/>
+                        </a:rPr>
+                        <a:t>0.016</a:t>
+                      </a:r>
+                    </a:p>
+                  </a:txBody>
+                  <a:tcPr marT="38100" marB="38100">
+                    <a:solidFill>
+                      <a:srgbClr val="E7F0E6"/>
+                    </a:solidFill>
+                  </a:tcPr>
+                </a:tc>
+              </a:tr>
+            </a:tbl>
+          </a:graphicData>
+        </a:graphic>
+      </p:graphicFrame>
       <p:sp>
         <p:nvSpPr>
           <p:cNvPr id="8" name="TextBox 7"/>
@@ -9217,8 +9999,8 @@
         </p:nvSpPr>
         <p:spPr>
           <a:xfrm>
-            <a:off x="502920" y="1764792"/>
-            <a:ext cx="2514600" cy="502920"/>
+            <a:off x="502920" y="2926080"/>
+            <a:ext cx="10789920" cy="365760"/>
           </a:xfrm>
           <a:prstGeom prst="rect">
             <a:avLst/>
@@ -9231,398 +10013,26 @@
           </a:bodyPr>
           <a:lstStyle/>
           <a:p>
-            <a:pPr algn="ctr">
+            <a:pPr algn="l">
               <a:lnSpc>
                 <a:spcPct val="100000"/>
               </a:lnSpc>
             </a:pPr>
             <a:r>
-              <a:rPr sz="1150" b="0" i="0">
-                <a:solidFill>
-                  <a:srgbClr val="5C6355"/>
-                </a:solidFill>
-                <a:latin typeface="Calibri"/>
-              </a:rPr>
-              <a:t>mean R² (across pixels × folds)</a:t>
-            </a:r>
-          </a:p>
-        </p:txBody>
-      </p:sp>
-      <p:sp>
-        <p:nvSpPr>
-          <p:cNvPr id="9" name="Rounded Rectangle 8"/>
-          <p:cNvSpPr/>
-          <p:nvPr/>
-        </p:nvSpPr>
-        <p:spPr>
-          <a:xfrm>
-            <a:off x="3273552" y="1143000"/>
-            <a:ext cx="2514600" cy="1005840"/>
-          </a:xfrm>
-          <a:prstGeom prst="roundRect">
-            <a:avLst>
-              <a:gd name="adj" fmla="val 12000"/>
-            </a:avLst>
-          </a:prstGeom>
-          <a:solidFill>
-            <a:srgbClr val="F3E2E8"/>
-          </a:solidFill>
-          <a:ln>
-            <a:noFill/>
-          </a:ln>
-          <a:effectLst/>
-        </p:spPr>
-        <p:style>
-          <a:lnRef idx="1">
-            <a:schemeClr val="accent1"/>
-          </a:lnRef>
-          <a:fillRef idx="3">
-            <a:schemeClr val="accent1"/>
-          </a:fillRef>
-          <a:effectRef idx="2">
-            <a:schemeClr val="accent1"/>
-          </a:effectRef>
-          <a:fontRef idx="minor">
-            <a:schemeClr val="lt1"/>
-          </a:fontRef>
-        </p:style>
-        <p:txBody>
-          <a:bodyPr rtlCol="0" anchor="ctr"/>
-          <a:lstStyle/>
-          <a:p>
-            <a:pPr algn="ctr"/>
-          </a:p>
-        </p:txBody>
-      </p:sp>
-      <p:sp>
-        <p:nvSpPr>
-          <p:cNvPr id="10" name="TextBox 9"/>
-          <p:cNvSpPr txBox="1"/>
-          <p:nvPr/>
-        </p:nvSpPr>
-        <p:spPr>
-          <a:xfrm>
-            <a:off x="3273552" y="1252728"/>
-            <a:ext cx="2514600" cy="502920"/>
-          </a:xfrm>
-          <a:prstGeom prst="rect">
-            <a:avLst/>
-          </a:prstGeom>
-          <a:noFill/>
-        </p:spPr>
-        <p:txBody>
-          <a:bodyPr wrap="square" anchor="t" lIns="0" rIns="0" tIns="0" bIns="0">
-            <a:spAutoFit/>
-          </a:bodyPr>
-          <a:lstStyle/>
-          <a:p>
-            <a:pPr algn="ctr">
-              <a:lnSpc>
-                <a:spcPct val="100000"/>
-              </a:lnSpc>
-            </a:pPr>
-            <a:r>
-              <a:rPr sz="2600" b="1" i="0">
-                <a:solidFill>
-                  <a:srgbClr val="6B1A33"/>
-                </a:solidFill>
-                <a:latin typeface="Calibri"/>
-              </a:rPr>
-              <a:t>0.400</a:t>
-            </a:r>
-          </a:p>
-        </p:txBody>
-      </p:sp>
-      <p:sp>
-        <p:nvSpPr>
-          <p:cNvPr id="11" name="TextBox 10"/>
-          <p:cNvSpPr txBox="1"/>
-          <p:nvPr/>
-        </p:nvSpPr>
-        <p:spPr>
-          <a:xfrm>
-            <a:off x="3273552" y="1764792"/>
-            <a:ext cx="2514600" cy="502920"/>
-          </a:xfrm>
-          <a:prstGeom prst="rect">
-            <a:avLst/>
-          </a:prstGeom>
-          <a:noFill/>
-        </p:spPr>
-        <p:txBody>
-          <a:bodyPr wrap="square" anchor="t" lIns="0" rIns="0" tIns="0" bIns="0">
-            <a:spAutoFit/>
-          </a:bodyPr>
-          <a:lstStyle/>
-          <a:p>
-            <a:pPr algn="ctr">
-              <a:lnSpc>
-                <a:spcPct val="100000"/>
-              </a:lnSpc>
-            </a:pPr>
-            <a:r>
-              <a:rPr sz="1150" b="0" i="0">
-                <a:solidFill>
-                  <a:srgbClr val="5C6355"/>
-                </a:solidFill>
-                <a:latin typeface="Calibri"/>
-              </a:rPr>
-              <a:t>mean of per-pixel median R²</a:t>
-            </a:r>
-          </a:p>
-        </p:txBody>
-      </p:sp>
-      <p:sp>
-        <p:nvSpPr>
-          <p:cNvPr id="12" name="Rounded Rectangle 11"/>
-          <p:cNvSpPr/>
-          <p:nvPr/>
-        </p:nvSpPr>
-        <p:spPr>
-          <a:xfrm>
-            <a:off x="6044184" y="1143000"/>
-            <a:ext cx="2514600" cy="1005840"/>
-          </a:xfrm>
-          <a:prstGeom prst="roundRect">
-            <a:avLst>
-              <a:gd name="adj" fmla="val 12000"/>
-            </a:avLst>
-          </a:prstGeom>
-          <a:solidFill>
-            <a:srgbClr val="F3E2E8"/>
-          </a:solidFill>
-          <a:ln>
-            <a:noFill/>
-          </a:ln>
-          <a:effectLst/>
-        </p:spPr>
-        <p:style>
-          <a:lnRef idx="1">
-            <a:schemeClr val="accent1"/>
-          </a:lnRef>
-          <a:fillRef idx="3">
-            <a:schemeClr val="accent1"/>
-          </a:fillRef>
-          <a:effectRef idx="2">
-            <a:schemeClr val="accent1"/>
-          </a:effectRef>
-          <a:fontRef idx="minor">
-            <a:schemeClr val="lt1"/>
-          </a:fontRef>
-        </p:style>
-        <p:txBody>
-          <a:bodyPr rtlCol="0" anchor="ctr"/>
-          <a:lstStyle/>
-          <a:p>
-            <a:pPr algn="ctr"/>
-          </a:p>
-        </p:txBody>
-      </p:sp>
-      <p:sp>
-        <p:nvSpPr>
-          <p:cNvPr id="13" name="TextBox 12"/>
-          <p:cNvSpPr txBox="1"/>
-          <p:nvPr/>
-        </p:nvSpPr>
-        <p:spPr>
-          <a:xfrm>
-            <a:off x="6044184" y="1252728"/>
-            <a:ext cx="2514600" cy="502920"/>
-          </a:xfrm>
-          <a:prstGeom prst="rect">
-            <a:avLst/>
-          </a:prstGeom>
-          <a:noFill/>
-        </p:spPr>
-        <p:txBody>
-          <a:bodyPr wrap="square" anchor="t" lIns="0" rIns="0" tIns="0" bIns="0">
-            <a:spAutoFit/>
-          </a:bodyPr>
-          <a:lstStyle/>
-          <a:p>
-            <a:pPr algn="ctr">
-              <a:lnSpc>
-                <a:spcPct val="100000"/>
-              </a:lnSpc>
-            </a:pPr>
-            <a:r>
-              <a:rPr sz="2600" b="1" i="0">
-                <a:solidFill>
-                  <a:srgbClr val="6B1A33"/>
-                </a:solidFill>
-                <a:latin typeface="Calibri"/>
-              </a:rPr>
-              <a:t>0.106</a:t>
-            </a:r>
-          </a:p>
-        </p:txBody>
-      </p:sp>
-      <p:sp>
-        <p:nvSpPr>
-          <p:cNvPr id="14" name="TextBox 13"/>
-          <p:cNvSpPr txBox="1"/>
-          <p:nvPr/>
-        </p:nvSpPr>
-        <p:spPr>
-          <a:xfrm>
-            <a:off x="6044184" y="1764792"/>
-            <a:ext cx="2514600" cy="502920"/>
-          </a:xfrm>
-          <a:prstGeom prst="rect">
-            <a:avLst/>
-          </a:prstGeom>
-          <a:noFill/>
-        </p:spPr>
-        <p:txBody>
-          <a:bodyPr wrap="square" anchor="t" lIns="0" rIns="0" tIns="0" bIns="0">
-            <a:spAutoFit/>
-          </a:bodyPr>
-          <a:lstStyle/>
-          <a:p>
-            <a:pPr algn="ctr">
-              <a:lnSpc>
-                <a:spcPct val="100000"/>
-              </a:lnSpc>
-            </a:pPr>
-            <a:r>
-              <a:rPr sz="1150" b="0" i="0">
-                <a:solidFill>
-                  <a:srgbClr val="5C6355"/>
-                </a:solidFill>
-                <a:latin typeface="Calibri"/>
-              </a:rPr>
-              <a:t>average variance (per-pixel)</a:t>
-            </a:r>
-          </a:p>
-        </p:txBody>
-      </p:sp>
-      <p:sp>
-        <p:nvSpPr>
-          <p:cNvPr id="15" name="Rounded Rectangle 14"/>
-          <p:cNvSpPr/>
-          <p:nvPr/>
-        </p:nvSpPr>
-        <p:spPr>
-          <a:xfrm>
-            <a:off x="8814816" y="1143000"/>
-            <a:ext cx="2514600" cy="1005840"/>
-          </a:xfrm>
-          <a:prstGeom prst="roundRect">
-            <a:avLst>
-              <a:gd name="adj" fmla="val 12000"/>
-            </a:avLst>
-          </a:prstGeom>
-          <a:solidFill>
-            <a:srgbClr val="F3E2E8"/>
-          </a:solidFill>
-          <a:ln>
-            <a:noFill/>
-          </a:ln>
-          <a:effectLst/>
-        </p:spPr>
-        <p:style>
-          <a:lnRef idx="1">
-            <a:schemeClr val="accent1"/>
-          </a:lnRef>
-          <a:fillRef idx="3">
-            <a:schemeClr val="accent1"/>
-          </a:fillRef>
-          <a:effectRef idx="2">
-            <a:schemeClr val="accent1"/>
-          </a:effectRef>
-          <a:fontRef idx="minor">
-            <a:schemeClr val="lt1"/>
-          </a:fontRef>
-        </p:style>
-        <p:txBody>
-          <a:bodyPr rtlCol="0" anchor="ctr"/>
-          <a:lstStyle/>
-          <a:p>
-            <a:pPr algn="ctr"/>
-          </a:p>
-        </p:txBody>
-      </p:sp>
-      <p:sp>
-        <p:nvSpPr>
-          <p:cNvPr id="16" name="TextBox 15"/>
-          <p:cNvSpPr txBox="1"/>
-          <p:nvPr/>
-        </p:nvSpPr>
-        <p:spPr>
-          <a:xfrm>
-            <a:off x="8814816" y="1252728"/>
-            <a:ext cx="2514600" cy="502920"/>
-          </a:xfrm>
-          <a:prstGeom prst="rect">
-            <a:avLst/>
-          </a:prstGeom>
-          <a:noFill/>
-        </p:spPr>
-        <p:txBody>
-          <a:bodyPr wrap="square" anchor="t" lIns="0" rIns="0" tIns="0" bIns="0">
-            <a:spAutoFit/>
-          </a:bodyPr>
-          <a:lstStyle/>
-          <a:p>
-            <a:pPr algn="ctr">
-              <a:lnSpc>
-                <a:spcPct val="100000"/>
-              </a:lnSpc>
-            </a:pPr>
-            <a:r>
-              <a:rPr sz="2600" b="1" i="0">
-                <a:solidFill>
-                  <a:srgbClr val="6B1A33"/>
-                </a:solidFill>
-                <a:latin typeface="Calibri"/>
-              </a:rPr>
-              <a:t>0.030</a:t>
-            </a:r>
-          </a:p>
-        </p:txBody>
-      </p:sp>
-      <p:sp>
-        <p:nvSpPr>
-          <p:cNvPr id="17" name="TextBox 16"/>
-          <p:cNvSpPr txBox="1"/>
-          <p:nvPr/>
-        </p:nvSpPr>
-        <p:spPr>
-          <a:xfrm>
-            <a:off x="8814816" y="1764792"/>
-            <a:ext cx="2514600" cy="502920"/>
-          </a:xfrm>
-          <a:prstGeom prst="rect">
-            <a:avLst/>
-          </a:prstGeom>
-          <a:noFill/>
-        </p:spPr>
-        <p:txBody>
-          <a:bodyPr wrap="square" anchor="t" lIns="0" rIns="0" tIns="0" bIns="0">
-            <a:spAutoFit/>
-          </a:bodyPr>
-          <a:lstStyle/>
-          <a:p>
-            <a:pPr algn="ctr">
-              <a:lnSpc>
-                <a:spcPct val="100000"/>
-              </a:lnSpc>
-            </a:pPr>
-            <a:r>
-              <a:rPr sz="1150" b="0" i="0">
-                <a:solidFill>
-                  <a:srgbClr val="5C6355"/>
-                </a:solidFill>
-                <a:latin typeface="Calibri"/>
-              </a:rPr>
-              <a:t>median variance (robust)</a:t>
+              <a:rPr sz="1250" b="1" i="1">
+                <a:solidFill>
+                  <a:srgbClr val="1C2119"/>
+                </a:solidFill>
+                <a:latin typeface="Calibri"/>
+              </a:rPr>
+              <a:t>Selection rule: top 20 of 68 pixels ranked BY mean LOYO-CV R² itself (2012–2022, 11 folds). Threshold: mean R² ≥ 0.594.</a:t>
             </a:r>
           </a:p>
         </p:txBody>
       </p:sp>
       <p:pic>
         <p:nvPicPr>
-          <p:cNvPr id="18" name="Picture 17" descr="loyo_global68_by_pixel.png"/>
+          <p:cNvPr id="9" name="Picture 8" descr="loyo_global_full_vs_top20_boxplot.png"/>
           <p:cNvPicPr>
             <a:picLocks noChangeAspect="1"/>
           </p:cNvPicPr>
@@ -9636,8 +10046,8 @@
         </p:blipFill>
         <p:spPr>
           <a:xfrm>
-            <a:off x="1270629" y="2377440"/>
-            <a:ext cx="9650436" cy="3584448"/>
+            <a:off x="2153254" y="3383280"/>
+            <a:ext cx="2185732" cy="1938528"/>
           </a:xfrm>
           <a:prstGeom prst="rect">
             <a:avLst/>
@@ -9646,7 +10056,86 @@
       </p:pic>
       <p:sp>
         <p:nvSpPr>
-          <p:cNvPr id="19" name="Rectangle 18"/>
+          <p:cNvPr id="10" name="TextBox 9"/>
+          <p:cNvSpPr txBox="1"/>
+          <p:nvPr/>
+        </p:nvSpPr>
+        <p:spPr>
+          <a:xfrm>
+            <a:off x="6263640" y="3474720"/>
+            <a:ext cx="5029200" cy="2468880"/>
+          </a:xfrm>
+          <a:prstGeom prst="rect">
+            <a:avLst/>
+          </a:prstGeom>
+          <a:noFill/>
+        </p:spPr>
+        <p:txBody>
+          <a:bodyPr wrap="square" anchor="t" lIns="0" rIns="0">
+            <a:spAutoFit/>
+          </a:bodyPr>
+          <a:lstStyle/>
+          <a:p>
+            <a:pPr>
+              <a:lnSpc>
+                <a:spcPct val="106000"/>
+              </a:lnSpc>
+              <a:spcAft>
+                <a:spcPts val="800"/>
+              </a:spcAft>
+            </a:pPr>
+            <a:r>
+              <a:rPr sz="1250">
+                <a:solidFill>
+                  <a:srgbClr val="8C1D40"/>
+                </a:solidFill>
+                <a:latin typeface="Calibri"/>
+              </a:rPr>
+              <a:t>▪  </a:t>
+            </a:r>
+            <a:r>
+              <a:rPr sz="1250">
+                <a:solidFill>
+                  <a:srgbClr val="1C2119"/>
+                </a:solidFill>
+                <a:latin typeface="Calibri"/>
+              </a:rPr>
+              <a:t>These 20 pixels are drawn from the same top-performer showcase on the previous slide — this is the same success cases, now quantified as a group.</a:t>
+            </a:r>
+          </a:p>
+          <a:p>
+            <a:pPr>
+              <a:lnSpc>
+                <a:spcPct val="106000"/>
+              </a:lnSpc>
+              <a:spcAft>
+                <a:spcPts val="800"/>
+              </a:spcAft>
+            </a:pPr>
+            <a:r>
+              <a:rPr sz="1250">
+                <a:solidFill>
+                  <a:srgbClr val="8C1D40"/>
+                </a:solidFill>
+                <a:latin typeface="Calibri"/>
+              </a:rPr>
+              <a:t>▪  </a:t>
+            </a:r>
+            <a:r>
+              <a:rPr sz="1250">
+                <a:solidFill>
+                  <a:srgbClr val="1C2119"/>
+                </a:solidFill>
+                <a:latin typeface="Calibri"/>
+              </a:rPr>
+              <a:t>Selecting on the outcome metric itself means this subset's statistics cannot be read as "what a typical non-CONUS pixel achieves" — that is what the full-pool row (and every other report/slide in this project) reports.</a:t>
+            </a:r>
+          </a:p>
+        </p:txBody>
+      </p:sp>
+      <p:sp>
+        <p:nvSpPr>
+          <p:cNvPr id="11" name="Rectangle 10"/>
           <p:cNvSpPr/>
           <p:nvPr/>
         </p:nvSpPr>
@@ -9659,7 +10148,7 @@
             <a:avLst/>
           </a:prstGeom>
           <a:solidFill>
-            <a:srgbClr val="F3E2E8"/>
+            <a:srgbClr val="FBEEE0"/>
           </a:solidFill>
           <a:ln>
             <a:noFill/>
@@ -9690,7 +10179,7 @@
       </p:sp>
       <p:sp>
         <p:nvSpPr>
-          <p:cNvPr id="20" name="Rectangle 19"/>
+          <p:cNvPr id="12" name="Rectangle 11"/>
           <p:cNvSpPr/>
           <p:nvPr/>
         </p:nvSpPr>
@@ -9703,7 +10192,7 @@
             <a:avLst/>
           </a:prstGeom>
           <a:solidFill>
-            <a:srgbClr val="8C1D40"/>
+            <a:srgbClr val="B5651D"/>
           </a:solidFill>
           <a:ln>
             <a:noFill/>
@@ -9734,7 +10223,7 @@
       </p:sp>
       <p:sp>
         <p:nvSpPr>
-          <p:cNvPr id="21" name="TextBox 20"/>
+          <p:cNvPr id="13" name="TextBox 12"/>
           <p:cNvSpPr txBox="1"/>
           <p:nvPr/>
         </p:nvSpPr>
@@ -9762,7 +10251,7 @@
             <a:r>
               <a:rPr sz="1200" b="1" i="0">
                 <a:solidFill>
-                  <a:srgbClr val="5A1228"/>
+                  <a:srgbClr val="7A3D0A"/>
                 </a:solidFill>
                 <a:latin typeface="Calibri"/>
               </a:rPr>
@@ -9773,7 +10262,7 @@
       </p:sp>
       <p:sp>
         <p:nvSpPr>
-          <p:cNvPr id="22" name="TextBox 21"/>
+          <p:cNvPr id="14" name="TextBox 13"/>
           <p:cNvSpPr txBox="1"/>
           <p:nvPr/>
         </p:nvSpPr>
@@ -9801,11 +10290,11 @@
             <a:r>
               <a:rPr sz="1450" b="1" i="0">
                 <a:solidFill>
-                  <a:srgbClr val="5A1228"/>
-                </a:solidFill>
-                <a:latin typeface="Calibri"/>
-              </a:rPr>
-              <a:t>Single-year (2022) median was 0.353; the 11-year mean R²=0.348 is consistent with it — the global result is weaker than CONUS but not a single-year artifact.</a:t>
+                  <a:srgbClr val="7A3D0A"/>
+                </a:solidFill>
+                <a:latin typeface="Calibri"/>
+              </a:rPr>
+              <a:t>Subset statistics are conditional on performance-based selection and are NOT representative of the full global pool. The full-pool result remains the primary, reported finding.</a:t>
             </a:r>
           </a:p>
         </p:txBody>
@@ -9870,7 +10359,7 @@
                 </a:solidFill>
                 <a:latin typeface="Calibri"/>
               </a:rPr>
-              <a:t>INTEGRATING BOTH POOLS</a:t>
+              <a:t>SECTION 2 — GLOBAL ROBUSTNESS CHECK</a:t>
             </a:r>
           </a:p>
         </p:txBody>
@@ -9909,7 +10398,7 @@
                 </a:solidFill>
                 <a:latin typeface="Calibri"/>
               </a:rPr>
-              <a:t>CONUS vs. Global: Variance Comparison</a:t>
+              <a:t>Global 68-Pixel Pool: LOYO-CV Results</a:t>
             </a:r>
           </a:p>
         </p:txBody>
@@ -9997,9 +10486,505 @@
           </a:p>
         </p:txBody>
       </p:sp>
+      <p:sp>
+        <p:nvSpPr>
+          <p:cNvPr id="6" name="Rounded Rectangle 5"/>
+          <p:cNvSpPr/>
+          <p:nvPr/>
+        </p:nvSpPr>
+        <p:spPr>
+          <a:xfrm>
+            <a:off x="502920" y="1143000"/>
+            <a:ext cx="2514600" cy="1005840"/>
+          </a:xfrm>
+          <a:prstGeom prst="roundRect">
+            <a:avLst>
+              <a:gd name="adj" fmla="val 12000"/>
+            </a:avLst>
+          </a:prstGeom>
+          <a:solidFill>
+            <a:srgbClr val="F3E2E8"/>
+          </a:solidFill>
+          <a:ln>
+            <a:noFill/>
+          </a:ln>
+          <a:effectLst/>
+        </p:spPr>
+        <p:style>
+          <a:lnRef idx="1">
+            <a:schemeClr val="accent1"/>
+          </a:lnRef>
+          <a:fillRef idx="3">
+            <a:schemeClr val="accent1"/>
+          </a:fillRef>
+          <a:effectRef idx="2">
+            <a:schemeClr val="accent1"/>
+          </a:effectRef>
+          <a:fontRef idx="minor">
+            <a:schemeClr val="lt1"/>
+          </a:fontRef>
+        </p:style>
+        <p:txBody>
+          <a:bodyPr rtlCol="0" anchor="ctr"/>
+          <a:lstStyle/>
+          <a:p>
+            <a:pPr algn="ctr"/>
+          </a:p>
+        </p:txBody>
+      </p:sp>
+      <p:sp>
+        <p:nvSpPr>
+          <p:cNvPr id="7" name="TextBox 6"/>
+          <p:cNvSpPr txBox="1"/>
+          <p:nvPr/>
+        </p:nvSpPr>
+        <p:spPr>
+          <a:xfrm>
+            <a:off x="502920" y="1252728"/>
+            <a:ext cx="2514600" cy="502920"/>
+          </a:xfrm>
+          <a:prstGeom prst="rect">
+            <a:avLst/>
+          </a:prstGeom>
+          <a:noFill/>
+        </p:spPr>
+        <p:txBody>
+          <a:bodyPr wrap="square" anchor="t" lIns="0" rIns="0" tIns="0" bIns="0">
+            <a:spAutoFit/>
+          </a:bodyPr>
+          <a:lstStyle/>
+          <a:p>
+            <a:pPr algn="ctr">
+              <a:lnSpc>
+                <a:spcPct val="100000"/>
+              </a:lnSpc>
+            </a:pPr>
+            <a:r>
+              <a:rPr sz="2600" b="1" i="0">
+                <a:solidFill>
+                  <a:srgbClr val="6B1A33"/>
+                </a:solidFill>
+                <a:latin typeface="Calibri"/>
+              </a:rPr>
+              <a:t>0.348</a:t>
+            </a:r>
+          </a:p>
+        </p:txBody>
+      </p:sp>
+      <p:sp>
+        <p:nvSpPr>
+          <p:cNvPr id="8" name="TextBox 7"/>
+          <p:cNvSpPr txBox="1"/>
+          <p:nvPr/>
+        </p:nvSpPr>
+        <p:spPr>
+          <a:xfrm>
+            <a:off x="502920" y="1764792"/>
+            <a:ext cx="2514600" cy="502920"/>
+          </a:xfrm>
+          <a:prstGeom prst="rect">
+            <a:avLst/>
+          </a:prstGeom>
+          <a:noFill/>
+        </p:spPr>
+        <p:txBody>
+          <a:bodyPr wrap="square" anchor="t" lIns="0" rIns="0" tIns="0" bIns="0">
+            <a:spAutoFit/>
+          </a:bodyPr>
+          <a:lstStyle/>
+          <a:p>
+            <a:pPr algn="ctr">
+              <a:lnSpc>
+                <a:spcPct val="100000"/>
+              </a:lnSpc>
+            </a:pPr>
+            <a:r>
+              <a:rPr sz="1150" b="0" i="0">
+                <a:solidFill>
+                  <a:srgbClr val="5C6355"/>
+                </a:solidFill>
+                <a:latin typeface="Calibri"/>
+              </a:rPr>
+              <a:t>mean R² (across pixels × folds)</a:t>
+            </a:r>
+          </a:p>
+        </p:txBody>
+      </p:sp>
+      <p:sp>
+        <p:nvSpPr>
+          <p:cNvPr id="9" name="Rounded Rectangle 8"/>
+          <p:cNvSpPr/>
+          <p:nvPr/>
+        </p:nvSpPr>
+        <p:spPr>
+          <a:xfrm>
+            <a:off x="3273552" y="1143000"/>
+            <a:ext cx="2514600" cy="1005840"/>
+          </a:xfrm>
+          <a:prstGeom prst="roundRect">
+            <a:avLst>
+              <a:gd name="adj" fmla="val 12000"/>
+            </a:avLst>
+          </a:prstGeom>
+          <a:solidFill>
+            <a:srgbClr val="F3E2E8"/>
+          </a:solidFill>
+          <a:ln>
+            <a:noFill/>
+          </a:ln>
+          <a:effectLst/>
+        </p:spPr>
+        <p:style>
+          <a:lnRef idx="1">
+            <a:schemeClr val="accent1"/>
+          </a:lnRef>
+          <a:fillRef idx="3">
+            <a:schemeClr val="accent1"/>
+          </a:fillRef>
+          <a:effectRef idx="2">
+            <a:schemeClr val="accent1"/>
+          </a:effectRef>
+          <a:fontRef idx="minor">
+            <a:schemeClr val="lt1"/>
+          </a:fontRef>
+        </p:style>
+        <p:txBody>
+          <a:bodyPr rtlCol="0" anchor="ctr"/>
+          <a:lstStyle/>
+          <a:p>
+            <a:pPr algn="ctr"/>
+          </a:p>
+        </p:txBody>
+      </p:sp>
+      <p:sp>
+        <p:nvSpPr>
+          <p:cNvPr id="10" name="TextBox 9"/>
+          <p:cNvSpPr txBox="1"/>
+          <p:nvPr/>
+        </p:nvSpPr>
+        <p:spPr>
+          <a:xfrm>
+            <a:off x="3273552" y="1252728"/>
+            <a:ext cx="2514600" cy="502920"/>
+          </a:xfrm>
+          <a:prstGeom prst="rect">
+            <a:avLst/>
+          </a:prstGeom>
+          <a:noFill/>
+        </p:spPr>
+        <p:txBody>
+          <a:bodyPr wrap="square" anchor="t" lIns="0" rIns="0" tIns="0" bIns="0">
+            <a:spAutoFit/>
+          </a:bodyPr>
+          <a:lstStyle/>
+          <a:p>
+            <a:pPr algn="ctr">
+              <a:lnSpc>
+                <a:spcPct val="100000"/>
+              </a:lnSpc>
+            </a:pPr>
+            <a:r>
+              <a:rPr sz="2600" b="1" i="0">
+                <a:solidFill>
+                  <a:srgbClr val="6B1A33"/>
+                </a:solidFill>
+                <a:latin typeface="Calibri"/>
+              </a:rPr>
+              <a:t>0.400</a:t>
+            </a:r>
+          </a:p>
+        </p:txBody>
+      </p:sp>
+      <p:sp>
+        <p:nvSpPr>
+          <p:cNvPr id="11" name="TextBox 10"/>
+          <p:cNvSpPr txBox="1"/>
+          <p:nvPr/>
+        </p:nvSpPr>
+        <p:spPr>
+          <a:xfrm>
+            <a:off x="3273552" y="1764792"/>
+            <a:ext cx="2514600" cy="502920"/>
+          </a:xfrm>
+          <a:prstGeom prst="rect">
+            <a:avLst/>
+          </a:prstGeom>
+          <a:noFill/>
+        </p:spPr>
+        <p:txBody>
+          <a:bodyPr wrap="square" anchor="t" lIns="0" rIns="0" tIns="0" bIns="0">
+            <a:spAutoFit/>
+          </a:bodyPr>
+          <a:lstStyle/>
+          <a:p>
+            <a:pPr algn="ctr">
+              <a:lnSpc>
+                <a:spcPct val="100000"/>
+              </a:lnSpc>
+            </a:pPr>
+            <a:r>
+              <a:rPr sz="1150" b="0" i="0">
+                <a:solidFill>
+                  <a:srgbClr val="5C6355"/>
+                </a:solidFill>
+                <a:latin typeface="Calibri"/>
+              </a:rPr>
+              <a:t>mean of per-pixel median R²</a:t>
+            </a:r>
+          </a:p>
+        </p:txBody>
+      </p:sp>
+      <p:sp>
+        <p:nvSpPr>
+          <p:cNvPr id="12" name="Rounded Rectangle 11"/>
+          <p:cNvSpPr/>
+          <p:nvPr/>
+        </p:nvSpPr>
+        <p:spPr>
+          <a:xfrm>
+            <a:off x="6044184" y="1143000"/>
+            <a:ext cx="2514600" cy="1005840"/>
+          </a:xfrm>
+          <a:prstGeom prst="roundRect">
+            <a:avLst>
+              <a:gd name="adj" fmla="val 12000"/>
+            </a:avLst>
+          </a:prstGeom>
+          <a:solidFill>
+            <a:srgbClr val="F3E2E8"/>
+          </a:solidFill>
+          <a:ln>
+            <a:noFill/>
+          </a:ln>
+          <a:effectLst/>
+        </p:spPr>
+        <p:style>
+          <a:lnRef idx="1">
+            <a:schemeClr val="accent1"/>
+          </a:lnRef>
+          <a:fillRef idx="3">
+            <a:schemeClr val="accent1"/>
+          </a:fillRef>
+          <a:effectRef idx="2">
+            <a:schemeClr val="accent1"/>
+          </a:effectRef>
+          <a:fontRef idx="minor">
+            <a:schemeClr val="lt1"/>
+          </a:fontRef>
+        </p:style>
+        <p:txBody>
+          <a:bodyPr rtlCol="0" anchor="ctr"/>
+          <a:lstStyle/>
+          <a:p>
+            <a:pPr algn="ctr"/>
+          </a:p>
+        </p:txBody>
+      </p:sp>
+      <p:sp>
+        <p:nvSpPr>
+          <p:cNvPr id="13" name="TextBox 12"/>
+          <p:cNvSpPr txBox="1"/>
+          <p:nvPr/>
+        </p:nvSpPr>
+        <p:spPr>
+          <a:xfrm>
+            <a:off x="6044184" y="1252728"/>
+            <a:ext cx="2514600" cy="502920"/>
+          </a:xfrm>
+          <a:prstGeom prst="rect">
+            <a:avLst/>
+          </a:prstGeom>
+          <a:noFill/>
+        </p:spPr>
+        <p:txBody>
+          <a:bodyPr wrap="square" anchor="t" lIns="0" rIns="0" tIns="0" bIns="0">
+            <a:spAutoFit/>
+          </a:bodyPr>
+          <a:lstStyle/>
+          <a:p>
+            <a:pPr algn="ctr">
+              <a:lnSpc>
+                <a:spcPct val="100000"/>
+              </a:lnSpc>
+            </a:pPr>
+            <a:r>
+              <a:rPr sz="2600" b="1" i="0">
+                <a:solidFill>
+                  <a:srgbClr val="6B1A33"/>
+                </a:solidFill>
+                <a:latin typeface="Calibri"/>
+              </a:rPr>
+              <a:t>0.106</a:t>
+            </a:r>
+          </a:p>
+        </p:txBody>
+      </p:sp>
+      <p:sp>
+        <p:nvSpPr>
+          <p:cNvPr id="14" name="TextBox 13"/>
+          <p:cNvSpPr txBox="1"/>
+          <p:nvPr/>
+        </p:nvSpPr>
+        <p:spPr>
+          <a:xfrm>
+            <a:off x="6044184" y="1764792"/>
+            <a:ext cx="2514600" cy="502920"/>
+          </a:xfrm>
+          <a:prstGeom prst="rect">
+            <a:avLst/>
+          </a:prstGeom>
+          <a:noFill/>
+        </p:spPr>
+        <p:txBody>
+          <a:bodyPr wrap="square" anchor="t" lIns="0" rIns="0" tIns="0" bIns="0">
+            <a:spAutoFit/>
+          </a:bodyPr>
+          <a:lstStyle/>
+          <a:p>
+            <a:pPr algn="ctr">
+              <a:lnSpc>
+                <a:spcPct val="100000"/>
+              </a:lnSpc>
+            </a:pPr>
+            <a:r>
+              <a:rPr sz="1150" b="0" i="0">
+                <a:solidFill>
+                  <a:srgbClr val="5C6355"/>
+                </a:solidFill>
+                <a:latin typeface="Calibri"/>
+              </a:rPr>
+              <a:t>average variance (per-pixel)</a:t>
+            </a:r>
+          </a:p>
+        </p:txBody>
+      </p:sp>
+      <p:sp>
+        <p:nvSpPr>
+          <p:cNvPr id="15" name="Rounded Rectangle 14"/>
+          <p:cNvSpPr/>
+          <p:nvPr/>
+        </p:nvSpPr>
+        <p:spPr>
+          <a:xfrm>
+            <a:off x="8814816" y="1143000"/>
+            <a:ext cx="2514600" cy="1005840"/>
+          </a:xfrm>
+          <a:prstGeom prst="roundRect">
+            <a:avLst>
+              <a:gd name="adj" fmla="val 12000"/>
+            </a:avLst>
+          </a:prstGeom>
+          <a:solidFill>
+            <a:srgbClr val="F3E2E8"/>
+          </a:solidFill>
+          <a:ln>
+            <a:noFill/>
+          </a:ln>
+          <a:effectLst/>
+        </p:spPr>
+        <p:style>
+          <a:lnRef idx="1">
+            <a:schemeClr val="accent1"/>
+          </a:lnRef>
+          <a:fillRef idx="3">
+            <a:schemeClr val="accent1"/>
+          </a:fillRef>
+          <a:effectRef idx="2">
+            <a:schemeClr val="accent1"/>
+          </a:effectRef>
+          <a:fontRef idx="minor">
+            <a:schemeClr val="lt1"/>
+          </a:fontRef>
+        </p:style>
+        <p:txBody>
+          <a:bodyPr rtlCol="0" anchor="ctr"/>
+          <a:lstStyle/>
+          <a:p>
+            <a:pPr algn="ctr"/>
+          </a:p>
+        </p:txBody>
+      </p:sp>
+      <p:sp>
+        <p:nvSpPr>
+          <p:cNvPr id="16" name="TextBox 15"/>
+          <p:cNvSpPr txBox="1"/>
+          <p:nvPr/>
+        </p:nvSpPr>
+        <p:spPr>
+          <a:xfrm>
+            <a:off x="8814816" y="1252728"/>
+            <a:ext cx="2514600" cy="502920"/>
+          </a:xfrm>
+          <a:prstGeom prst="rect">
+            <a:avLst/>
+          </a:prstGeom>
+          <a:noFill/>
+        </p:spPr>
+        <p:txBody>
+          <a:bodyPr wrap="square" anchor="t" lIns="0" rIns="0" tIns="0" bIns="0">
+            <a:spAutoFit/>
+          </a:bodyPr>
+          <a:lstStyle/>
+          <a:p>
+            <a:pPr algn="ctr">
+              <a:lnSpc>
+                <a:spcPct val="100000"/>
+              </a:lnSpc>
+            </a:pPr>
+            <a:r>
+              <a:rPr sz="2600" b="1" i="0">
+                <a:solidFill>
+                  <a:srgbClr val="6B1A33"/>
+                </a:solidFill>
+                <a:latin typeface="Calibri"/>
+              </a:rPr>
+              <a:t>0.030</a:t>
+            </a:r>
+          </a:p>
+        </p:txBody>
+      </p:sp>
+      <p:sp>
+        <p:nvSpPr>
+          <p:cNvPr id="17" name="TextBox 16"/>
+          <p:cNvSpPr txBox="1"/>
+          <p:nvPr/>
+        </p:nvSpPr>
+        <p:spPr>
+          <a:xfrm>
+            <a:off x="8814816" y="1764792"/>
+            <a:ext cx="2514600" cy="502920"/>
+          </a:xfrm>
+          <a:prstGeom prst="rect">
+            <a:avLst/>
+          </a:prstGeom>
+          <a:noFill/>
+        </p:spPr>
+        <p:txBody>
+          <a:bodyPr wrap="square" anchor="t" lIns="0" rIns="0" tIns="0" bIns="0">
+            <a:spAutoFit/>
+          </a:bodyPr>
+          <a:lstStyle/>
+          <a:p>
+            <a:pPr algn="ctr">
+              <a:lnSpc>
+                <a:spcPct val="100000"/>
+              </a:lnSpc>
+            </a:pPr>
+            <a:r>
+              <a:rPr sz="1150" b="0" i="0">
+                <a:solidFill>
+                  <a:srgbClr val="5C6355"/>
+                </a:solidFill>
+                <a:latin typeface="Calibri"/>
+              </a:rPr>
+              <a:t>median variance (robust)</a:t>
+            </a:r>
+          </a:p>
+        </p:txBody>
+      </p:sp>
       <p:pic>
         <p:nvPicPr>
-          <p:cNvPr id="6" name="Picture 5" descr="loyo_variance_comparison.png"/>
+          <p:cNvPr id="18" name="Picture 17" descr="loyo_global68_by_pixel.png"/>
           <p:cNvPicPr>
             <a:picLocks noChangeAspect="1"/>
           </p:cNvPicPr>
@@ -10013,8 +10998,8 @@
         </p:blipFill>
         <p:spPr>
           <a:xfrm>
-            <a:off x="502920" y="1152603"/>
-            <a:ext cx="11185855" cy="4845402"/>
+            <a:off x="1270629" y="2377440"/>
+            <a:ext cx="9650436" cy="3584448"/>
           </a:xfrm>
           <a:prstGeom prst="rect">
             <a:avLst/>
@@ -10023,7 +11008,7 @@
       </p:pic>
       <p:sp>
         <p:nvSpPr>
-          <p:cNvPr id="7" name="Rectangle 6"/>
+          <p:cNvPr id="19" name="Rectangle 18"/>
           <p:cNvSpPr/>
           <p:nvPr/>
         </p:nvSpPr>
@@ -10036,7 +11021,7 @@
             <a:avLst/>
           </a:prstGeom>
           <a:solidFill>
-            <a:srgbClr val="E7F0E6"/>
+            <a:srgbClr val="F3E2E8"/>
           </a:solidFill>
           <a:ln>
             <a:noFill/>
@@ -10067,7 +11052,7 @@
       </p:sp>
       <p:sp>
         <p:nvSpPr>
-          <p:cNvPr id="8" name="Rectangle 7"/>
+          <p:cNvPr id="20" name="Rectangle 19"/>
           <p:cNvSpPr/>
           <p:nvPr/>
         </p:nvSpPr>
@@ -10080,7 +11065,7 @@
             <a:avLst/>
           </a:prstGeom>
           <a:solidFill>
-            <a:srgbClr val="2F6F5E"/>
+            <a:srgbClr val="8C1D40"/>
           </a:solidFill>
           <a:ln>
             <a:noFill/>
@@ -10111,7 +11096,7 @@
       </p:sp>
       <p:sp>
         <p:nvSpPr>
-          <p:cNvPr id="9" name="TextBox 8"/>
+          <p:cNvPr id="21" name="TextBox 20"/>
           <p:cNvSpPr txBox="1"/>
           <p:nvPr/>
         </p:nvSpPr>
@@ -10139,7 +11124,7 @@
             <a:r>
               <a:rPr sz="1200" b="1" i="0">
                 <a:solidFill>
-                  <a:srgbClr val="1E4A33"/>
+                  <a:srgbClr val="5A1228"/>
                 </a:solidFill>
                 <a:latin typeface="Calibri"/>
               </a:rPr>
@@ -10150,7 +11135,7 @@
       </p:sp>
       <p:sp>
         <p:nvSpPr>
-          <p:cNvPr id="10" name="TextBox 9"/>
+          <p:cNvPr id="22" name="TextBox 21"/>
           <p:cNvSpPr txBox="1"/>
           <p:nvPr/>
         </p:nvSpPr>
@@ -10178,11 +11163,11 @@
             <a:r>
               <a:rPr sz="1450" b="1" i="0">
                 <a:solidFill>
-                  <a:srgbClr val="1E4A33"/>
-                </a:solidFill>
-                <a:latin typeface="Calibri"/>
-              </a:rPr>
-              <a:t>Typical variance is lower for CONUS (0.005 vs. Global's 0.030) — but CONUS has a longer extreme-outlier tail (e.g. evergreen's 2012 drought fold).</a:t>
+                  <a:srgbClr val="5A1228"/>
+                </a:solidFill>
+                <a:latin typeface="Calibri"/>
+              </a:rPr>
+              <a:t>Single-year (2022) median was 0.353; the 11-year mean R²=0.348 is consistent with it — the global result is weaker than CONUS but not a single-year artifact.</a:t>
             </a:r>
           </a:p>
         </p:txBody>

</xml_diff>